<commit_message>
Updating 2/4 and 2/9 and links
</commit_message>
<xml_diff>
--- a/slides/0204-Scientific_Literature.pptx
+++ b/slides/0204-Scientific_Literature.pptx
@@ -10,8 +10,8 @@
   <p:sldIdLst>
     <p:sldId id="256" r:id="rId2"/>
     <p:sldId id="258" r:id="rId3"/>
-    <p:sldId id="259" r:id="rId4"/>
-    <p:sldId id="260" r:id="rId5"/>
+    <p:sldId id="260" r:id="rId4"/>
+    <p:sldId id="259" r:id="rId5"/>
     <p:sldId id="261" r:id="rId6"/>
   </p:sldIdLst>
   <p:sldSz cx="24384000" cy="13716000"/>
@@ -2437,7 +2437,7 @@
           </a:ln>
           <a:extLst>
             <a:ext uri="{C572A759-6A51-4108-AA02-DFA0A04FC94B}">
-              <ma14:wrappingTextBoxFlag xmlns="" xmlns:m="http://schemas.openxmlformats.org/officeDocument/2006/math" xmlns:a14="http://schemas.microsoft.com/office/drawing/2010/main" xmlns:ma14="http://schemas.microsoft.com/office/mac/drawingml/2011/main" val="1"/>
+              <ma14:wrappingTextBoxFlag xmlns:ma14="http://schemas.microsoft.com/office/mac/drawingml/2011/main" xmlns:a14="http://schemas.microsoft.com/office/drawing/2010/main" xmlns:m="http://schemas.openxmlformats.org/officeDocument/2006/math" xmlns="" val="1"/>
             </a:ext>
           </a:extLst>
         </p:spPr>
@@ -2476,7 +2476,7 @@
           </a:ln>
           <a:extLst>
             <a:ext uri="{C572A759-6A51-4108-AA02-DFA0A04FC94B}">
-              <ma14:wrappingTextBoxFlag xmlns="" xmlns:m="http://schemas.openxmlformats.org/officeDocument/2006/math" xmlns:a14="http://schemas.microsoft.com/office/drawing/2010/main" xmlns:ma14="http://schemas.microsoft.com/office/mac/drawingml/2011/main" val="1"/>
+              <ma14:wrappingTextBoxFlag xmlns:ma14="http://schemas.microsoft.com/office/mac/drawingml/2011/main" xmlns:a14="http://schemas.microsoft.com/office/drawing/2010/main" xmlns:m="http://schemas.openxmlformats.org/officeDocument/2006/math" xmlns="" val="1"/>
             </a:ext>
           </a:extLst>
         </p:spPr>
@@ -3370,8 +3370,55 @@
           </a:prstGeom>
         </p:spPr>
         <p:txBody>
-          <a:bodyPr/>
+          <a:bodyPr>
+            <a:normAutofit/>
+          </a:bodyPr>
           <a:lstStyle/>
+          <a:p>
+            <a:r>
+              <a:rPr lang="en-US" dirty="0"/>
+              <a:t>Comments on </a:t>
+            </a:r>
+          </a:p>
+          <a:p>
+            <a:pPr lvl="1"/>
+            <a:r>
+              <a:rPr lang="en-US" dirty="0"/>
+              <a:t>Quiz: make sure to understand foundational material</a:t>
+            </a:r>
+          </a:p>
+          <a:p>
+            <a:pPr lvl="1"/>
+            <a:r>
+              <a:rPr lang="en-US" dirty="0"/>
+              <a:t>Exercise 3</a:t>
+            </a:r>
+          </a:p>
+          <a:p>
+            <a:pPr lvl="2"/>
+            <a:r>
+              <a:rPr lang="en-US" dirty="0"/>
+              <a:t>Confirm MOR:G</a:t>
+            </a:r>
+            <a:r>
+              <a:rPr lang="el-GR" dirty="0"/>
+              <a:t>α</a:t>
+            </a:r>
+            <a:r>
+              <a:rPr lang="en-US" dirty="0"/>
+              <a:t> instability</a:t>
+            </a:r>
+          </a:p>
+          <a:p>
+            <a:pPr lvl="2"/>
+            <a:r>
+              <a:rPr lang="en-US" dirty="0"/>
+              <a:t>Carry over to Exercise 4</a:t>
+            </a:r>
+            <a:endParaRPr lang="en-US" u="sng" dirty="0">
+              <a:hlinkClick r:id="rId2"/>
+            </a:endParaRPr>
+          </a:p>
           <a:p>
             <a:r>
               <a:rPr u="sng" dirty="0">
@@ -3397,19 +3444,11 @@
             </a:r>
           </a:p>
           <a:p>
-            <a:pPr lvl="2"/>
+            <a:pPr lvl="1"/>
             <a:r>
               <a:rPr lang="en-US" dirty="0"/>
-              <a:t>Scientific literature</a:t>
-            </a:r>
-          </a:p>
-          <a:p>
-            <a:pPr lvl="2"/>
-            <a:r>
-              <a:rPr lang="en-US" dirty="0"/>
-              <a:t>Biological activity</a:t>
-            </a:r>
-            <a:endParaRPr dirty="0"/>
+              <a:t>Search strategies</a:t>
+            </a:r>
           </a:p>
           <a:p>
             <a:pPr lvl="1"/>
@@ -3422,12 +3461,6 @@
             <a:pPr lvl="1"/>
             <a:r>
               <a:rPr dirty="0"/>
-              <a:t>Search strategies</a:t>
-            </a:r>
-          </a:p>
-          <a:p>
-            <a:pPr lvl="1"/>
-            <a:r>
               <a:t>Zotero</a:t>
             </a:r>
             <a:endParaRPr lang="en-US" dirty="0"/>
@@ -3454,7 +3487,7 @@
           </a:prstGeom>
           <a:extLst>
             <a:ext uri="{C572A759-6A51-4108-AA02-DFA0A04FC94B}">
-              <ma14:wrappingTextBoxFlag xmlns="" xmlns:m="http://schemas.openxmlformats.org/officeDocument/2006/math" xmlns:a14="http://schemas.microsoft.com/office/drawing/2010/main" xmlns:ma14="http://schemas.microsoft.com/office/mac/drawingml/2011/main" val="1"/>
+              <ma14:wrappingTextBoxFlag xmlns:ma14="http://schemas.microsoft.com/office/mac/drawingml/2011/main" xmlns:a14="http://schemas.microsoft.com/office/drawing/2010/main" xmlns:m="http://schemas.openxmlformats.org/officeDocument/2006/math" xmlns="" val="1"/>
             </a:ext>
           </a:extLst>
         </p:spPr>
@@ -3685,7 +3718,7 @@
           </a:prstGeom>
           <a:extLst>
             <a:ext uri="{C572A759-6A51-4108-AA02-DFA0A04FC94B}">
-              <ma14:wrappingTextBoxFlag xmlns="" xmlns:m="http://schemas.openxmlformats.org/officeDocument/2006/math" xmlns:a14="http://schemas.microsoft.com/office/drawing/2010/main" xmlns:ma14="http://schemas.microsoft.com/office/mac/drawingml/2011/main" val="1"/>
+              <ma14:wrappingTextBoxFlag xmlns:ma14="http://schemas.microsoft.com/office/mac/drawingml/2011/main" xmlns:a14="http://schemas.microsoft.com/office/drawing/2010/main" xmlns:m="http://schemas.openxmlformats.org/officeDocument/2006/math" xmlns="" val="1"/>
             </a:ext>
           </a:extLst>
         </p:spPr>
@@ -3711,177 +3744,6 @@
 </file>
 
 <file path=ppt/slides/slide3.xml><?xml version="1.0" encoding="utf-8"?>
-<p:sld xmlns:a="http://schemas.openxmlformats.org/drawingml/2006/main" xmlns:r="http://schemas.openxmlformats.org/officeDocument/2006/relationships" xmlns:p="http://schemas.openxmlformats.org/presentationml/2006/main">
-  <p:cSld>
-    <p:spTree>
-      <p:nvGrpSpPr>
-        <p:cNvPr id="1" name=""/>
-        <p:cNvGrpSpPr/>
-        <p:nvPr/>
-      </p:nvGrpSpPr>
-      <p:grpSpPr>
-        <a:xfrm>
-          <a:off x="0" y="0"/>
-          <a:ext cx="0" cy="0"/>
-          <a:chOff x="0" y="0"/>
-          <a:chExt cx="0" cy="0"/>
-        </a:xfrm>
-      </p:grpSpPr>
-      <p:sp>
-        <p:nvSpPr>
-          <p:cNvPr id="150" name="Accessing articles"/>
-          <p:cNvSpPr txBox="1">
-            <a:spLocks noGrp="1"/>
-          </p:cNvSpPr>
-          <p:nvPr>
-            <p:ph type="title"/>
-          </p:nvPr>
-        </p:nvSpPr>
-        <p:spPr>
-          <a:prstGeom prst="rect">
-            <a:avLst/>
-          </a:prstGeom>
-        </p:spPr>
-        <p:txBody>
-          <a:bodyPr/>
-          <a:lstStyle/>
-          <a:p>
-            <a:r>
-              <a:t>Accessing articles</a:t>
-            </a:r>
-          </a:p>
-        </p:txBody>
-      </p:sp>
-      <p:sp>
-        <p:nvSpPr>
-          <p:cNvPr id="151" name="Free…"/>
-          <p:cNvSpPr txBox="1">
-            <a:spLocks noGrp="1"/>
-          </p:cNvSpPr>
-          <p:nvPr>
-            <p:ph type="body" idx="1"/>
-          </p:nvPr>
-        </p:nvSpPr>
-        <p:spPr>
-          <a:prstGeom prst="rect">
-            <a:avLst/>
-          </a:prstGeom>
-        </p:spPr>
-        <p:txBody>
-          <a:bodyPr/>
-          <a:lstStyle/>
-          <a:p>
-            <a:r>
-              <a:t>Free</a:t>
-            </a:r>
-          </a:p>
-          <a:p>
-            <a:pPr lvl="1"/>
-            <a:r>
-              <a:t>Open access - article is free online. Usually requires larger author payment</a:t>
-            </a:r>
-          </a:p>
-          <a:p>
-            <a:pPr lvl="1"/>
-            <a:r>
-              <a:t>Many NIH-funded articles are available online after one year</a:t>
-            </a:r>
-          </a:p>
-          <a:p>
-            <a:pPr lvl="1"/>
-            <a:r>
-              <a:t>Preprint servers, e.g. bioarXiv - free, but may not be peer reviewed</a:t>
-            </a:r>
-          </a:p>
-          <a:p>
-            <a:pPr lvl="1"/>
-            <a:r>
-              <a:t>Sometimes available from authors on their websites or upon request</a:t>
-            </a:r>
-          </a:p>
-          <a:p>
-            <a:r>
-              <a:t>Paywall</a:t>
-            </a:r>
-          </a:p>
-          <a:p>
-            <a:pPr lvl="1"/>
-            <a:r>
-              <a:t>IIT subscribes to a selection of scientific journals, which can be accessed</a:t>
-            </a:r>
-          </a:p>
-          <a:p>
-            <a:pPr lvl="2"/>
-            <a:r>
-              <a:t>in the library</a:t>
-            </a:r>
-          </a:p>
-          <a:p>
-            <a:pPr lvl="2"/>
-            <a:r>
-              <a:t>online from campus</a:t>
-            </a:r>
-          </a:p>
-          <a:p>
-            <a:pPr lvl="2"/>
-            <a:r>
-              <a:t>via a proxy server or VPN</a:t>
-            </a:r>
-          </a:p>
-          <a:p>
-            <a:pPr lvl="1"/>
-            <a:r>
-              <a:t>Interlibrary loan (MyILL) can be used to request nearly any article, but requires a lead time</a:t>
-            </a:r>
-          </a:p>
-        </p:txBody>
-      </p:sp>
-      <p:sp>
-        <p:nvSpPr>
-          <p:cNvPr id="152" name="Slide Number"/>
-          <p:cNvSpPr txBox="1">
-            <a:spLocks noGrp="1"/>
-          </p:cNvSpPr>
-          <p:nvPr>
-            <p:ph type="sldNum" sz="quarter" idx="2"/>
-          </p:nvPr>
-        </p:nvSpPr>
-        <p:spPr>
-          <a:xfrm>
-            <a:off x="12020548" y="13010554"/>
-            <a:ext cx="325045" cy="511176"/>
-          </a:xfrm>
-          <a:prstGeom prst="rect">
-            <a:avLst/>
-          </a:prstGeom>
-          <a:extLst>
-            <a:ext uri="{C572A759-6A51-4108-AA02-DFA0A04FC94B}">
-              <ma14:wrappingTextBoxFlag xmlns="" xmlns:m="http://schemas.openxmlformats.org/officeDocument/2006/math" xmlns:a14="http://schemas.microsoft.com/office/drawing/2010/main" xmlns:ma14="http://schemas.microsoft.com/office/mac/drawingml/2011/main" val="1"/>
-            </a:ext>
-          </a:extLst>
-        </p:spPr>
-        <p:txBody>
-          <a:bodyPr/>
-          <a:lstStyle/>
-          <a:p>
-            <a:fld id="{86CB4B4D-7CA3-9044-876B-883B54F8677D}" type="slidenum">
-              <a:rPr/>
-              <a:t>3</a:t>
-            </a:fld>
-            <a:endParaRPr/>
-          </a:p>
-        </p:txBody>
-      </p:sp>
-    </p:spTree>
-  </p:cSld>
-  <p:clrMapOvr>
-    <a:masterClrMapping/>
-  </p:clrMapOvr>
-  <p:transition spd="med"/>
-</p:sld>
-</file>
-
-<file path=ppt/slides/slide4.xml><?xml version="1.0" encoding="utf-8"?>
 <p:sld xmlns:a="http://schemas.openxmlformats.org/drawingml/2006/main" xmlns:r="http://schemas.openxmlformats.org/officeDocument/2006/relationships" xmlns:p="http://schemas.openxmlformats.org/presentationml/2006/main">
   <p:cSld>
     <p:spTree>
@@ -3995,7 +3857,7 @@
           </a:prstGeom>
           <a:extLst>
             <a:ext uri="{C572A759-6A51-4108-AA02-DFA0A04FC94B}">
-              <ma14:wrappingTextBoxFlag xmlns="" xmlns:m="http://schemas.openxmlformats.org/officeDocument/2006/math" xmlns:a14="http://schemas.microsoft.com/office/drawing/2010/main" xmlns:ma14="http://schemas.microsoft.com/office/mac/drawingml/2011/main" val="1"/>
+              <ma14:wrappingTextBoxFlag xmlns:ma14="http://schemas.microsoft.com/office/mac/drawingml/2011/main" xmlns:a14="http://schemas.microsoft.com/office/drawing/2010/main" xmlns:m="http://schemas.openxmlformats.org/officeDocument/2006/math" xmlns="" val="1"/>
             </a:ext>
           </a:extLst>
         </p:spPr>
@@ -4005,7 +3867,7 @@
           <a:p>
             <a:fld id="{86CB4B4D-7CA3-9044-876B-883B54F8677D}" type="slidenum">
               <a:rPr/>
-              <a:t>4</a:t>
+              <a:t>3</a:t>
             </a:fld>
             <a:endParaRPr/>
           </a:p>
@@ -4333,6 +4195,177 @@
 </p:sld>
 </file>
 
+<file path=ppt/slides/slide4.xml><?xml version="1.0" encoding="utf-8"?>
+<p:sld xmlns:a="http://schemas.openxmlformats.org/drawingml/2006/main" xmlns:r="http://schemas.openxmlformats.org/officeDocument/2006/relationships" xmlns:p="http://schemas.openxmlformats.org/presentationml/2006/main">
+  <p:cSld>
+    <p:spTree>
+      <p:nvGrpSpPr>
+        <p:cNvPr id="1" name=""/>
+        <p:cNvGrpSpPr/>
+        <p:nvPr/>
+      </p:nvGrpSpPr>
+      <p:grpSpPr>
+        <a:xfrm>
+          <a:off x="0" y="0"/>
+          <a:ext cx="0" cy="0"/>
+          <a:chOff x="0" y="0"/>
+          <a:chExt cx="0" cy="0"/>
+        </a:xfrm>
+      </p:grpSpPr>
+      <p:sp>
+        <p:nvSpPr>
+          <p:cNvPr id="150" name="Accessing articles"/>
+          <p:cNvSpPr txBox="1">
+            <a:spLocks noGrp="1"/>
+          </p:cNvSpPr>
+          <p:nvPr>
+            <p:ph type="title"/>
+          </p:nvPr>
+        </p:nvSpPr>
+        <p:spPr>
+          <a:prstGeom prst="rect">
+            <a:avLst/>
+          </a:prstGeom>
+        </p:spPr>
+        <p:txBody>
+          <a:bodyPr/>
+          <a:lstStyle/>
+          <a:p>
+            <a:r>
+              <a:t>Accessing articles</a:t>
+            </a:r>
+          </a:p>
+        </p:txBody>
+      </p:sp>
+      <p:sp>
+        <p:nvSpPr>
+          <p:cNvPr id="151" name="Free…"/>
+          <p:cNvSpPr txBox="1">
+            <a:spLocks noGrp="1"/>
+          </p:cNvSpPr>
+          <p:nvPr>
+            <p:ph type="body" idx="1"/>
+          </p:nvPr>
+        </p:nvSpPr>
+        <p:spPr>
+          <a:prstGeom prst="rect">
+            <a:avLst/>
+          </a:prstGeom>
+        </p:spPr>
+        <p:txBody>
+          <a:bodyPr/>
+          <a:lstStyle/>
+          <a:p>
+            <a:r>
+              <a:t>Free</a:t>
+            </a:r>
+          </a:p>
+          <a:p>
+            <a:pPr lvl="1"/>
+            <a:r>
+              <a:t>Open access - article is free online. Usually requires larger author payment</a:t>
+            </a:r>
+          </a:p>
+          <a:p>
+            <a:pPr lvl="1"/>
+            <a:r>
+              <a:t>Many NIH-funded articles are available online after one year</a:t>
+            </a:r>
+          </a:p>
+          <a:p>
+            <a:pPr lvl="1"/>
+            <a:r>
+              <a:t>Preprint servers, e.g. bioarXiv - free, but may not be peer reviewed</a:t>
+            </a:r>
+          </a:p>
+          <a:p>
+            <a:pPr lvl="1"/>
+            <a:r>
+              <a:t>Sometimes available from authors on their websites or upon request</a:t>
+            </a:r>
+          </a:p>
+          <a:p>
+            <a:r>
+              <a:t>Paywall</a:t>
+            </a:r>
+          </a:p>
+          <a:p>
+            <a:pPr lvl="1"/>
+            <a:r>
+              <a:t>IIT subscribes to a selection of scientific journals, which can be accessed</a:t>
+            </a:r>
+          </a:p>
+          <a:p>
+            <a:pPr lvl="2"/>
+            <a:r>
+              <a:t>in the library</a:t>
+            </a:r>
+          </a:p>
+          <a:p>
+            <a:pPr lvl="2"/>
+            <a:r>
+              <a:t>online from campus</a:t>
+            </a:r>
+          </a:p>
+          <a:p>
+            <a:pPr lvl="2"/>
+            <a:r>
+              <a:t>via a proxy server or VPN</a:t>
+            </a:r>
+          </a:p>
+          <a:p>
+            <a:pPr lvl="1"/>
+            <a:r>
+              <a:t>Interlibrary loan (MyILL) can be used to request nearly any article, but requires a lead time</a:t>
+            </a:r>
+          </a:p>
+        </p:txBody>
+      </p:sp>
+      <p:sp>
+        <p:nvSpPr>
+          <p:cNvPr id="152" name="Slide Number"/>
+          <p:cNvSpPr txBox="1">
+            <a:spLocks noGrp="1"/>
+          </p:cNvSpPr>
+          <p:nvPr>
+            <p:ph type="sldNum" sz="quarter" idx="2"/>
+          </p:nvPr>
+        </p:nvSpPr>
+        <p:spPr>
+          <a:xfrm>
+            <a:off x="12020548" y="13010554"/>
+            <a:ext cx="325045" cy="511176"/>
+          </a:xfrm>
+          <a:prstGeom prst="rect">
+            <a:avLst/>
+          </a:prstGeom>
+          <a:extLst>
+            <a:ext uri="{C572A759-6A51-4108-AA02-DFA0A04FC94B}">
+              <ma14:wrappingTextBoxFlag xmlns:ma14="http://schemas.microsoft.com/office/mac/drawingml/2011/main" xmlns:a14="http://schemas.microsoft.com/office/drawing/2010/main" xmlns:m="http://schemas.openxmlformats.org/officeDocument/2006/math" xmlns="" val="1"/>
+            </a:ext>
+          </a:extLst>
+        </p:spPr>
+        <p:txBody>
+          <a:bodyPr/>
+          <a:lstStyle/>
+          <a:p>
+            <a:fld id="{86CB4B4D-7CA3-9044-876B-883B54F8677D}" type="slidenum">
+              <a:rPr/>
+              <a:t>4</a:t>
+            </a:fld>
+            <a:endParaRPr/>
+          </a:p>
+        </p:txBody>
+      </p:sp>
+    </p:spTree>
+  </p:cSld>
+  <p:clrMapOvr>
+    <a:masterClrMapping/>
+  </p:clrMapOvr>
+  <p:transition spd="med"/>
+</p:sld>
+</file>
+
 <file path=ppt/slides/slide5.xml><?xml version="1.0" encoding="utf-8"?>
 <p:sld xmlns:a="http://schemas.openxmlformats.org/drawingml/2006/main" xmlns:r="http://schemas.openxmlformats.org/officeDocument/2006/relationships" xmlns:p="http://schemas.openxmlformats.org/presentationml/2006/main">
   <p:cSld>
@@ -4452,7 +4485,7 @@
           </a:prstGeom>
           <a:extLst>
             <a:ext uri="{C572A759-6A51-4108-AA02-DFA0A04FC94B}">
-              <ma14:wrappingTextBoxFlag xmlns="" xmlns:m="http://schemas.openxmlformats.org/officeDocument/2006/math" xmlns:a14="http://schemas.microsoft.com/office/drawing/2010/main" xmlns:ma14="http://schemas.microsoft.com/office/mac/drawingml/2011/main" val="1"/>
+              <ma14:wrappingTextBoxFlag xmlns:ma14="http://schemas.microsoft.com/office/mac/drawingml/2011/main" xmlns:a14="http://schemas.microsoft.com/office/drawing/2010/main" xmlns:m="http://schemas.openxmlformats.org/officeDocument/2006/math" xmlns="" val="1"/>
             </a:ext>
           </a:extLst>
         </p:spPr>

</xml_diff>